<commit_message>
Updated CS 0007 Recitation 1 slides.
</commit_message>
<xml_diff>
--- a/files/CS0007/CS_0007_Recitation_1.pptx
+++ b/files/CS0007/CS_0007_Recitation_1.pptx
@@ -8,9 +8,10 @@
     <p:sldId id="256" r:id="rId2"/>
     <p:sldId id="257" r:id="rId3"/>
     <p:sldId id="258" r:id="rId4"/>
-    <p:sldId id="259" r:id="rId5"/>
-    <p:sldId id="260" r:id="rId6"/>
-    <p:sldId id="261" r:id="rId7"/>
+    <p:sldId id="262" r:id="rId5"/>
+    <p:sldId id="259" r:id="rId6"/>
+    <p:sldId id="260" r:id="rId7"/>
+    <p:sldId id="261" r:id="rId8"/>
   </p:sldIdLst>
   <p:sldSz cx="12192000" cy="6858000"/>
   <p:notesSz cx="6858000" cy="9144000"/>
@@ -5982,6 +5983,18 @@
   <p:clrMapOvr>
     <a:masterClrMapping/>
   </p:clrMapOvr>
+  <mc:AlternateContent xmlns:mc="http://schemas.openxmlformats.org/markup-compatibility/2006">
+    <mc:Choice xmlns:p14="http://schemas.microsoft.com/office/powerpoint/2010/main" Requires="p14">
+      <p:transition spd="med" p14:dur="700">
+        <p:fade/>
+      </p:transition>
+    </mc:Choice>
+    <mc:Fallback>
+      <p:transition spd="med">
+        <p:fade/>
+      </p:transition>
+    </mc:Fallback>
+  </mc:AlternateContent>
 </p:sld>
 </file>
 
@@ -6132,6 +6145,247 @@
   <p:clrMapOvr>
     <a:masterClrMapping/>
   </p:clrMapOvr>
+  <mc:AlternateContent xmlns:mc="http://schemas.openxmlformats.org/markup-compatibility/2006">
+    <mc:Choice xmlns:p14="http://schemas.microsoft.com/office/powerpoint/2010/main" Requires="p14">
+      <p:transition spd="med" p14:dur="700">
+        <p:fade/>
+      </p:transition>
+    </mc:Choice>
+    <mc:Fallback>
+      <p:transition spd="med">
+        <p:fade/>
+      </p:transition>
+    </mc:Fallback>
+  </mc:AlternateContent>
+  <p:timing>
+    <p:tnLst>
+      <p:par>
+        <p:cTn id="1" dur="indefinite" restart="never" nodeType="tmRoot">
+          <p:childTnLst>
+            <p:seq concurrent="1" nextAc="seek">
+              <p:cTn id="2" dur="indefinite" nodeType="mainSeq">
+                <p:childTnLst>
+                  <p:par>
+                    <p:cTn id="3" fill="hold">
+                      <p:stCondLst>
+                        <p:cond delay="indefinite"/>
+                      </p:stCondLst>
+                      <p:childTnLst>
+                        <p:par>
+                          <p:cTn id="4" fill="hold">
+                            <p:stCondLst>
+                              <p:cond delay="0"/>
+                            </p:stCondLst>
+                            <p:childTnLst>
+                              <p:par>
+                                <p:cTn id="5" presetID="1" presetClass="entr" presetSubtype="0" fill="hold" grpId="0" nodeType="clickEffect">
+                                  <p:stCondLst>
+                                    <p:cond delay="0"/>
+                                  </p:stCondLst>
+                                  <p:childTnLst>
+                                    <p:set>
+                                      <p:cBhvr>
+                                        <p:cTn id="6" dur="1" fill="hold">
+                                          <p:stCondLst>
+                                            <p:cond delay="0"/>
+                                          </p:stCondLst>
+                                        </p:cTn>
+                                        <p:tgtEl>
+                                          <p:spTgt spid="3">
+                                            <p:txEl>
+                                              <p:pRg st="0" end="0"/>
+                                            </p:txEl>
+                                          </p:spTgt>
+                                        </p:tgtEl>
+                                        <p:attrNameLst>
+                                          <p:attrName>style.visibility</p:attrName>
+                                        </p:attrNameLst>
+                                      </p:cBhvr>
+                                      <p:to>
+                                        <p:strVal val="visible"/>
+                                      </p:to>
+                                    </p:set>
+                                  </p:childTnLst>
+                                </p:cTn>
+                              </p:par>
+                            </p:childTnLst>
+                          </p:cTn>
+                        </p:par>
+                      </p:childTnLst>
+                    </p:cTn>
+                  </p:par>
+                  <p:par>
+                    <p:cTn id="7" fill="hold">
+                      <p:stCondLst>
+                        <p:cond delay="indefinite"/>
+                      </p:stCondLst>
+                      <p:childTnLst>
+                        <p:par>
+                          <p:cTn id="8" fill="hold">
+                            <p:stCondLst>
+                              <p:cond delay="0"/>
+                            </p:stCondLst>
+                            <p:childTnLst>
+                              <p:par>
+                                <p:cTn id="9" presetID="1" presetClass="entr" presetSubtype="0" fill="hold" grpId="0" nodeType="clickEffect">
+                                  <p:stCondLst>
+                                    <p:cond delay="0"/>
+                                  </p:stCondLst>
+                                  <p:childTnLst>
+                                    <p:set>
+                                      <p:cBhvr>
+                                        <p:cTn id="10" dur="1" fill="hold">
+                                          <p:stCondLst>
+                                            <p:cond delay="0"/>
+                                          </p:stCondLst>
+                                        </p:cTn>
+                                        <p:tgtEl>
+                                          <p:spTgt spid="3">
+                                            <p:txEl>
+                                              <p:pRg st="1" end="1"/>
+                                            </p:txEl>
+                                          </p:spTgt>
+                                        </p:tgtEl>
+                                        <p:attrNameLst>
+                                          <p:attrName>style.visibility</p:attrName>
+                                        </p:attrNameLst>
+                                      </p:cBhvr>
+                                      <p:to>
+                                        <p:strVal val="visible"/>
+                                      </p:to>
+                                    </p:set>
+                                  </p:childTnLst>
+                                </p:cTn>
+                              </p:par>
+                            </p:childTnLst>
+                          </p:cTn>
+                        </p:par>
+                      </p:childTnLst>
+                    </p:cTn>
+                  </p:par>
+                  <p:par>
+                    <p:cTn id="11" fill="hold">
+                      <p:stCondLst>
+                        <p:cond delay="indefinite"/>
+                      </p:stCondLst>
+                      <p:childTnLst>
+                        <p:par>
+                          <p:cTn id="12" fill="hold">
+                            <p:stCondLst>
+                              <p:cond delay="0"/>
+                            </p:stCondLst>
+                            <p:childTnLst>
+                              <p:par>
+                                <p:cTn id="13" presetID="1" presetClass="entr" presetSubtype="0" fill="hold" grpId="0" nodeType="clickEffect">
+                                  <p:stCondLst>
+                                    <p:cond delay="0"/>
+                                  </p:stCondLst>
+                                  <p:childTnLst>
+                                    <p:set>
+                                      <p:cBhvr>
+                                        <p:cTn id="14" dur="1" fill="hold">
+                                          <p:stCondLst>
+                                            <p:cond delay="0"/>
+                                          </p:stCondLst>
+                                        </p:cTn>
+                                        <p:tgtEl>
+                                          <p:spTgt spid="3">
+                                            <p:txEl>
+                                              <p:pRg st="2" end="2"/>
+                                            </p:txEl>
+                                          </p:spTgt>
+                                        </p:tgtEl>
+                                        <p:attrNameLst>
+                                          <p:attrName>style.visibility</p:attrName>
+                                        </p:attrNameLst>
+                                      </p:cBhvr>
+                                      <p:to>
+                                        <p:strVal val="visible"/>
+                                      </p:to>
+                                    </p:set>
+                                  </p:childTnLst>
+                                </p:cTn>
+                              </p:par>
+                            </p:childTnLst>
+                          </p:cTn>
+                        </p:par>
+                      </p:childTnLst>
+                    </p:cTn>
+                  </p:par>
+                  <p:par>
+                    <p:cTn id="15" fill="hold">
+                      <p:stCondLst>
+                        <p:cond delay="indefinite"/>
+                      </p:stCondLst>
+                      <p:childTnLst>
+                        <p:par>
+                          <p:cTn id="16" fill="hold">
+                            <p:stCondLst>
+                              <p:cond delay="0"/>
+                            </p:stCondLst>
+                            <p:childTnLst>
+                              <p:par>
+                                <p:cTn id="17" presetID="1" presetClass="entr" presetSubtype="0" fill="hold" grpId="0" nodeType="clickEffect">
+                                  <p:stCondLst>
+                                    <p:cond delay="0"/>
+                                  </p:stCondLst>
+                                  <p:childTnLst>
+                                    <p:set>
+                                      <p:cBhvr>
+                                        <p:cTn id="18" dur="1" fill="hold">
+                                          <p:stCondLst>
+                                            <p:cond delay="0"/>
+                                          </p:stCondLst>
+                                        </p:cTn>
+                                        <p:tgtEl>
+                                          <p:spTgt spid="3">
+                                            <p:txEl>
+                                              <p:pRg st="4" end="4"/>
+                                            </p:txEl>
+                                          </p:spTgt>
+                                        </p:tgtEl>
+                                        <p:attrNameLst>
+                                          <p:attrName>style.visibility</p:attrName>
+                                        </p:attrNameLst>
+                                      </p:cBhvr>
+                                      <p:to>
+                                        <p:strVal val="visible"/>
+                                      </p:to>
+                                    </p:set>
+                                  </p:childTnLst>
+                                </p:cTn>
+                              </p:par>
+                            </p:childTnLst>
+                          </p:cTn>
+                        </p:par>
+                      </p:childTnLst>
+                    </p:cTn>
+                  </p:par>
+                </p:childTnLst>
+              </p:cTn>
+              <p:prevCondLst>
+                <p:cond evt="onPrev" delay="0">
+                  <p:tgtEl>
+                    <p:sldTgt/>
+                  </p:tgtEl>
+                </p:cond>
+              </p:prevCondLst>
+              <p:nextCondLst>
+                <p:cond evt="onNext" delay="0">
+                  <p:tgtEl>
+                    <p:sldTgt/>
+                  </p:tgtEl>
+                </p:cond>
+              </p:nextCondLst>
+            </p:seq>
+          </p:childTnLst>
+        </p:cTn>
+      </p:par>
+    </p:tnLst>
+    <p:bldLst>
+      <p:bldP spid="3" grpId="0" build="p"/>
+    </p:bldLst>
+  </p:timing>
 </p:sld>
 </file>
 
@@ -6238,9 +6492,27 @@
             <a:endParaRPr lang="en-US" dirty="0"/>
           </a:p>
           <a:p>
-            <a:pPr>
-              <a:buFontTx/>
-              <a:buChar char="-"/>
+            <a:pPr marL="0" indent="0">
+              <a:buNone/>
+            </a:pPr>
+            <a:r>
+              <a:rPr lang="en-US" dirty="0"/>
+              <a:t>Or you can use the following link:</a:t>
+            </a:r>
+            <a:br>
+              <a:rPr lang="en-US" dirty="0"/>
+            </a:br>
+            <a:r>
+              <a:rPr lang="en-US" dirty="0">
+                <a:hlinkClick r:id="rId3"/>
+              </a:rPr>
+              <a:t>https://adoptopenjdk.net/?variant=openjdk13&amp;jvmVariant=hotspot</a:t>
+            </a:r>
+            <a:endParaRPr lang="en-US" dirty="0"/>
+          </a:p>
+          <a:p>
+            <a:pPr marL="0" indent="0">
+              <a:buNone/>
             </a:pPr>
             <a:endParaRPr lang="en-US" dirty="0"/>
           </a:p>
@@ -6256,6 +6528,247 @@
   <p:clrMapOvr>
     <a:masterClrMapping/>
   </p:clrMapOvr>
+  <mc:AlternateContent xmlns:mc="http://schemas.openxmlformats.org/markup-compatibility/2006">
+    <mc:Choice xmlns:p14="http://schemas.microsoft.com/office/powerpoint/2010/main" Requires="p14">
+      <p:transition spd="med" p14:dur="700">
+        <p:fade/>
+      </p:transition>
+    </mc:Choice>
+    <mc:Fallback>
+      <p:transition spd="med">
+        <p:fade/>
+      </p:transition>
+    </mc:Fallback>
+  </mc:AlternateContent>
+  <p:timing>
+    <p:tnLst>
+      <p:par>
+        <p:cTn id="1" dur="indefinite" restart="never" nodeType="tmRoot">
+          <p:childTnLst>
+            <p:seq concurrent="1" nextAc="seek">
+              <p:cTn id="2" dur="indefinite" nodeType="mainSeq">
+                <p:childTnLst>
+                  <p:par>
+                    <p:cTn id="3" fill="hold">
+                      <p:stCondLst>
+                        <p:cond delay="indefinite"/>
+                      </p:stCondLst>
+                      <p:childTnLst>
+                        <p:par>
+                          <p:cTn id="4" fill="hold">
+                            <p:stCondLst>
+                              <p:cond delay="0"/>
+                            </p:stCondLst>
+                            <p:childTnLst>
+                              <p:par>
+                                <p:cTn id="5" presetID="1" presetClass="entr" presetSubtype="0" fill="hold" grpId="0" nodeType="clickEffect">
+                                  <p:stCondLst>
+                                    <p:cond delay="0"/>
+                                  </p:stCondLst>
+                                  <p:childTnLst>
+                                    <p:set>
+                                      <p:cBhvr>
+                                        <p:cTn id="6" dur="1" fill="hold">
+                                          <p:stCondLst>
+                                            <p:cond delay="0"/>
+                                          </p:stCondLst>
+                                        </p:cTn>
+                                        <p:tgtEl>
+                                          <p:spTgt spid="3">
+                                            <p:txEl>
+                                              <p:pRg st="0" end="0"/>
+                                            </p:txEl>
+                                          </p:spTgt>
+                                        </p:tgtEl>
+                                        <p:attrNameLst>
+                                          <p:attrName>style.visibility</p:attrName>
+                                        </p:attrNameLst>
+                                      </p:cBhvr>
+                                      <p:to>
+                                        <p:strVal val="visible"/>
+                                      </p:to>
+                                    </p:set>
+                                  </p:childTnLst>
+                                </p:cTn>
+                              </p:par>
+                            </p:childTnLst>
+                          </p:cTn>
+                        </p:par>
+                      </p:childTnLst>
+                    </p:cTn>
+                  </p:par>
+                  <p:par>
+                    <p:cTn id="7" fill="hold">
+                      <p:stCondLst>
+                        <p:cond delay="indefinite"/>
+                      </p:stCondLst>
+                      <p:childTnLst>
+                        <p:par>
+                          <p:cTn id="8" fill="hold">
+                            <p:stCondLst>
+                              <p:cond delay="0"/>
+                            </p:stCondLst>
+                            <p:childTnLst>
+                              <p:par>
+                                <p:cTn id="9" presetID="1" presetClass="entr" presetSubtype="0" fill="hold" grpId="0" nodeType="clickEffect">
+                                  <p:stCondLst>
+                                    <p:cond delay="0"/>
+                                  </p:stCondLst>
+                                  <p:childTnLst>
+                                    <p:set>
+                                      <p:cBhvr>
+                                        <p:cTn id="10" dur="1" fill="hold">
+                                          <p:stCondLst>
+                                            <p:cond delay="0"/>
+                                          </p:stCondLst>
+                                        </p:cTn>
+                                        <p:tgtEl>
+                                          <p:spTgt spid="3">
+                                            <p:txEl>
+                                              <p:pRg st="1" end="1"/>
+                                            </p:txEl>
+                                          </p:spTgt>
+                                        </p:tgtEl>
+                                        <p:attrNameLst>
+                                          <p:attrName>style.visibility</p:attrName>
+                                        </p:attrNameLst>
+                                      </p:cBhvr>
+                                      <p:to>
+                                        <p:strVal val="visible"/>
+                                      </p:to>
+                                    </p:set>
+                                  </p:childTnLst>
+                                </p:cTn>
+                              </p:par>
+                            </p:childTnLst>
+                          </p:cTn>
+                        </p:par>
+                      </p:childTnLst>
+                    </p:cTn>
+                  </p:par>
+                  <p:par>
+                    <p:cTn id="11" fill="hold">
+                      <p:stCondLst>
+                        <p:cond delay="indefinite"/>
+                      </p:stCondLst>
+                      <p:childTnLst>
+                        <p:par>
+                          <p:cTn id="12" fill="hold">
+                            <p:stCondLst>
+                              <p:cond delay="0"/>
+                            </p:stCondLst>
+                            <p:childTnLst>
+                              <p:par>
+                                <p:cTn id="13" presetID="1" presetClass="entr" presetSubtype="0" fill="hold" grpId="0" nodeType="clickEffect">
+                                  <p:stCondLst>
+                                    <p:cond delay="0"/>
+                                  </p:stCondLst>
+                                  <p:childTnLst>
+                                    <p:set>
+                                      <p:cBhvr>
+                                        <p:cTn id="14" dur="1" fill="hold">
+                                          <p:stCondLst>
+                                            <p:cond delay="0"/>
+                                          </p:stCondLst>
+                                        </p:cTn>
+                                        <p:tgtEl>
+                                          <p:spTgt spid="3">
+                                            <p:txEl>
+                                              <p:pRg st="2" end="2"/>
+                                            </p:txEl>
+                                          </p:spTgt>
+                                        </p:tgtEl>
+                                        <p:attrNameLst>
+                                          <p:attrName>style.visibility</p:attrName>
+                                        </p:attrNameLst>
+                                      </p:cBhvr>
+                                      <p:to>
+                                        <p:strVal val="visible"/>
+                                      </p:to>
+                                    </p:set>
+                                  </p:childTnLst>
+                                </p:cTn>
+                              </p:par>
+                            </p:childTnLst>
+                          </p:cTn>
+                        </p:par>
+                      </p:childTnLst>
+                    </p:cTn>
+                  </p:par>
+                  <p:par>
+                    <p:cTn id="15" fill="hold">
+                      <p:stCondLst>
+                        <p:cond delay="indefinite"/>
+                      </p:stCondLst>
+                      <p:childTnLst>
+                        <p:par>
+                          <p:cTn id="16" fill="hold">
+                            <p:stCondLst>
+                              <p:cond delay="0"/>
+                            </p:stCondLst>
+                            <p:childTnLst>
+                              <p:par>
+                                <p:cTn id="17" presetID="1" presetClass="entr" presetSubtype="0" fill="hold" grpId="0" nodeType="clickEffect">
+                                  <p:stCondLst>
+                                    <p:cond delay="0"/>
+                                  </p:stCondLst>
+                                  <p:childTnLst>
+                                    <p:set>
+                                      <p:cBhvr>
+                                        <p:cTn id="18" dur="1" fill="hold">
+                                          <p:stCondLst>
+                                            <p:cond delay="0"/>
+                                          </p:stCondLst>
+                                        </p:cTn>
+                                        <p:tgtEl>
+                                          <p:spTgt spid="3">
+                                            <p:txEl>
+                                              <p:pRg st="3" end="3"/>
+                                            </p:txEl>
+                                          </p:spTgt>
+                                        </p:tgtEl>
+                                        <p:attrNameLst>
+                                          <p:attrName>style.visibility</p:attrName>
+                                        </p:attrNameLst>
+                                      </p:cBhvr>
+                                      <p:to>
+                                        <p:strVal val="visible"/>
+                                      </p:to>
+                                    </p:set>
+                                  </p:childTnLst>
+                                </p:cTn>
+                              </p:par>
+                            </p:childTnLst>
+                          </p:cTn>
+                        </p:par>
+                      </p:childTnLst>
+                    </p:cTn>
+                  </p:par>
+                </p:childTnLst>
+              </p:cTn>
+              <p:prevCondLst>
+                <p:cond evt="onPrev" delay="0">
+                  <p:tgtEl>
+                    <p:sldTgt/>
+                  </p:tgtEl>
+                </p:cond>
+              </p:prevCondLst>
+              <p:nextCondLst>
+                <p:cond evt="onNext" delay="0">
+                  <p:tgtEl>
+                    <p:sldTgt/>
+                  </p:tgtEl>
+                </p:cond>
+              </p:nextCondLst>
+            </p:seq>
+          </p:childTnLst>
+        </p:cTn>
+      </p:par>
+    </p:tnLst>
+    <p:bldLst>
+      <p:bldP spid="3" grpId="0" build="p"/>
+    </p:bldLst>
+  </p:timing>
 </p:sld>
 </file>
 
@@ -6281,6 +6794,608 @@
           <p:cNvPr id="2" name="Title 1">
             <a:extLst>
               <a:ext uri="{FF2B5EF4-FFF2-40B4-BE49-F238E27FC236}">
+                <a16:creationId xmlns:a16="http://schemas.microsoft.com/office/drawing/2014/main" id="{11F8BF7F-81FD-4FBD-B72A-C4AC6574CA3D}"/>
+              </a:ext>
+            </a:extLst>
+          </p:cNvPr>
+          <p:cNvSpPr>
+            <a:spLocks noGrp="1"/>
+          </p:cNvSpPr>
+          <p:nvPr>
+            <p:ph type="title"/>
+          </p:nvPr>
+        </p:nvSpPr>
+        <p:spPr/>
+        <p:txBody>
+          <a:bodyPr/>
+          <a:lstStyle/>
+          <a:p>
+            <a:r>
+              <a:rPr lang="en-US" dirty="0"/>
+              <a:t>OpenJDK</a:t>
+            </a:r>
+          </a:p>
+        </p:txBody>
+      </p:sp>
+      <p:sp>
+        <p:nvSpPr>
+          <p:cNvPr id="3" name="Content Placeholder 2">
+            <a:extLst>
+              <a:ext uri="{FF2B5EF4-FFF2-40B4-BE49-F238E27FC236}">
+                <a16:creationId xmlns:a16="http://schemas.microsoft.com/office/drawing/2014/main" id="{D18CD29C-2D11-4123-820E-A8330B6F8EA9}"/>
+              </a:ext>
+            </a:extLst>
+          </p:cNvPr>
+          <p:cNvSpPr>
+            <a:spLocks noGrp="1"/>
+          </p:cNvSpPr>
+          <p:nvPr>
+            <p:ph idx="1"/>
+          </p:nvPr>
+        </p:nvSpPr>
+        <p:spPr/>
+        <p:txBody>
+          <a:bodyPr>
+            <a:normAutofit fontScale="92500" lnSpcReduction="20000"/>
+          </a:bodyPr>
+          <a:lstStyle/>
+          <a:p>
+            <a:r>
+              <a:rPr lang="en-US" dirty="0"/>
+              <a:t>If you downloaded with the first link, this doesn’t apply to you.</a:t>
+            </a:r>
+          </a:p>
+          <a:p>
+            <a:r>
+              <a:rPr lang="en-US" dirty="0"/>
+              <a:t>Once OpenJDK has been downloaded to your computer, </a:t>
+            </a:r>
+            <a:r>
+              <a:rPr lang="en-US" b="1" dirty="0"/>
+              <a:t>run the installer</a:t>
+            </a:r>
+            <a:r>
+              <a:rPr lang="en-US" dirty="0"/>
+              <a:t>.</a:t>
+            </a:r>
+          </a:p>
+          <a:p>
+            <a:pPr marL="0" indent="0">
+              <a:buNone/>
+            </a:pPr>
+            <a:endParaRPr lang="en-US" dirty="0"/>
+          </a:p>
+          <a:p>
+            <a:r>
+              <a:rPr lang="en-US" dirty="0"/>
+              <a:t>Make sure that the </a:t>
+            </a:r>
+            <a:r>
+              <a:rPr lang="en-US" b="1" dirty="0"/>
+              <a:t>Add the installation to the PATH environment variable option is checked </a:t>
+            </a:r>
+            <a:r>
+              <a:rPr lang="en-US" dirty="0"/>
+              <a:t>while you’re following the prompts!</a:t>
+            </a:r>
+          </a:p>
+          <a:p>
+            <a:r>
+              <a:rPr lang="en-US" dirty="0"/>
+              <a:t>Run the command </a:t>
+            </a:r>
+            <a:r>
+              <a:rPr lang="en-US" b="1" dirty="0" err="1"/>
+              <a:t>javac</a:t>
+            </a:r>
+            <a:r>
+              <a:rPr lang="en-US" b="1" dirty="0"/>
+              <a:t> –version </a:t>
+            </a:r>
+            <a:endParaRPr lang="en-US" dirty="0"/>
+          </a:p>
+          <a:p>
+            <a:pPr>
+              <a:buFontTx/>
+              <a:buChar char="-"/>
+            </a:pPr>
+            <a:r>
+              <a:rPr lang="en-US" dirty="0"/>
+              <a:t>If you get something like this:</a:t>
+            </a:r>
+          </a:p>
+          <a:p>
+            <a:pPr>
+              <a:buFontTx/>
+              <a:buChar char="-"/>
+            </a:pPr>
+            <a:r>
+              <a:rPr lang="en-US" dirty="0" err="1"/>
+              <a:t>Ya</a:t>
+            </a:r>
+            <a:r>
+              <a:rPr lang="en-US" dirty="0"/>
+              <a:t> did it right </a:t>
+            </a:r>
+            <a:r>
+              <a:rPr lang="en-US" dirty="0">
+                <a:sym typeface="Wingdings" panose="05000000000000000000" pitchFamily="2" charset="2"/>
+              </a:rPr>
+              <a:t></a:t>
+            </a:r>
+            <a:endParaRPr lang="en-US" dirty="0"/>
+          </a:p>
+          <a:p>
+            <a:pPr>
+              <a:buFontTx/>
+              <a:buChar char="-"/>
+            </a:pPr>
+            <a:endParaRPr lang="en-US" dirty="0"/>
+          </a:p>
+          <a:p>
+            <a:pPr>
+              <a:buFontTx/>
+              <a:buChar char="-"/>
+            </a:pPr>
+            <a:endParaRPr lang="en-US" dirty="0"/>
+          </a:p>
+          <a:p>
+            <a:endParaRPr lang="en-US" dirty="0"/>
+          </a:p>
+          <a:p>
+            <a:endParaRPr lang="en-US" dirty="0"/>
+          </a:p>
+        </p:txBody>
+      </p:sp>
+      <p:pic>
+        <p:nvPicPr>
+          <p:cNvPr id="5" name="Picture 4">
+            <a:extLst>
+              <a:ext uri="{FF2B5EF4-FFF2-40B4-BE49-F238E27FC236}">
+                <a16:creationId xmlns:a16="http://schemas.microsoft.com/office/drawing/2014/main" id="{EFFF1080-90D7-4772-8920-ABD9439F3F77}"/>
+              </a:ext>
+            </a:extLst>
+          </p:cNvPr>
+          <p:cNvPicPr>
+            <a:picLocks noChangeAspect="1"/>
+          </p:cNvPicPr>
+          <p:nvPr/>
+        </p:nvPicPr>
+        <p:blipFill>
+          <a:blip r:embed="rId2"/>
+          <a:stretch>
+            <a:fillRect/>
+          </a:stretch>
+        </p:blipFill>
+        <p:spPr>
+          <a:xfrm>
+            <a:off x="5016636" y="4846763"/>
+            <a:ext cx="2781300" cy="552450"/>
+          </a:xfrm>
+          <a:prstGeom prst="rect">
+            <a:avLst/>
+          </a:prstGeom>
+        </p:spPr>
+      </p:pic>
+    </p:spTree>
+    <p:extLst>
+      <p:ext uri="{BB962C8B-B14F-4D97-AF65-F5344CB8AC3E}">
+        <p14:creationId xmlns:p14="http://schemas.microsoft.com/office/powerpoint/2010/main" val="2683341551"/>
+      </p:ext>
+    </p:extLst>
+  </p:cSld>
+  <p:clrMapOvr>
+    <a:masterClrMapping/>
+  </p:clrMapOvr>
+  <mc:AlternateContent xmlns:mc="http://schemas.openxmlformats.org/markup-compatibility/2006">
+    <mc:Choice xmlns:p14="http://schemas.microsoft.com/office/powerpoint/2010/main" Requires="p14">
+      <p:transition spd="med" p14:dur="700">
+        <p:fade/>
+      </p:transition>
+    </mc:Choice>
+    <mc:Fallback>
+      <p:transition spd="med">
+        <p:fade/>
+      </p:transition>
+    </mc:Fallback>
+  </mc:AlternateContent>
+  <p:timing>
+    <p:tnLst>
+      <p:par>
+        <p:cTn id="1" dur="indefinite" restart="never" nodeType="tmRoot">
+          <p:childTnLst>
+            <p:seq concurrent="1" nextAc="seek">
+              <p:cTn id="2" dur="indefinite" nodeType="mainSeq">
+                <p:childTnLst>
+                  <p:par>
+                    <p:cTn id="3" fill="hold">
+                      <p:stCondLst>
+                        <p:cond delay="indefinite"/>
+                      </p:stCondLst>
+                      <p:childTnLst>
+                        <p:par>
+                          <p:cTn id="4" fill="hold">
+                            <p:stCondLst>
+                              <p:cond delay="0"/>
+                            </p:stCondLst>
+                            <p:childTnLst>
+                              <p:par>
+                                <p:cTn id="5" presetID="1" presetClass="entr" presetSubtype="0" fill="hold" grpId="0" nodeType="clickEffect">
+                                  <p:stCondLst>
+                                    <p:cond delay="0"/>
+                                  </p:stCondLst>
+                                  <p:childTnLst>
+                                    <p:set>
+                                      <p:cBhvr>
+                                        <p:cTn id="6" dur="1" fill="hold">
+                                          <p:stCondLst>
+                                            <p:cond delay="0"/>
+                                          </p:stCondLst>
+                                        </p:cTn>
+                                        <p:tgtEl>
+                                          <p:spTgt spid="3">
+                                            <p:txEl>
+                                              <p:pRg st="0" end="0"/>
+                                            </p:txEl>
+                                          </p:spTgt>
+                                        </p:tgtEl>
+                                        <p:attrNameLst>
+                                          <p:attrName>style.visibility</p:attrName>
+                                        </p:attrNameLst>
+                                      </p:cBhvr>
+                                      <p:to>
+                                        <p:strVal val="visible"/>
+                                      </p:to>
+                                    </p:set>
+                                  </p:childTnLst>
+                                </p:cTn>
+                              </p:par>
+                            </p:childTnLst>
+                          </p:cTn>
+                        </p:par>
+                      </p:childTnLst>
+                    </p:cTn>
+                  </p:par>
+                  <p:par>
+                    <p:cTn id="7" fill="hold">
+                      <p:stCondLst>
+                        <p:cond delay="indefinite"/>
+                      </p:stCondLst>
+                      <p:childTnLst>
+                        <p:par>
+                          <p:cTn id="8" fill="hold">
+                            <p:stCondLst>
+                              <p:cond delay="0"/>
+                            </p:stCondLst>
+                            <p:childTnLst>
+                              <p:par>
+                                <p:cTn id="9" presetID="1" presetClass="entr" presetSubtype="0" fill="hold" grpId="0" nodeType="clickEffect">
+                                  <p:stCondLst>
+                                    <p:cond delay="0"/>
+                                  </p:stCondLst>
+                                  <p:childTnLst>
+                                    <p:set>
+                                      <p:cBhvr>
+                                        <p:cTn id="10" dur="1" fill="hold">
+                                          <p:stCondLst>
+                                            <p:cond delay="0"/>
+                                          </p:stCondLst>
+                                        </p:cTn>
+                                        <p:tgtEl>
+                                          <p:spTgt spid="3">
+                                            <p:txEl>
+                                              <p:pRg st="1" end="1"/>
+                                            </p:txEl>
+                                          </p:spTgt>
+                                        </p:tgtEl>
+                                        <p:attrNameLst>
+                                          <p:attrName>style.visibility</p:attrName>
+                                        </p:attrNameLst>
+                                      </p:cBhvr>
+                                      <p:to>
+                                        <p:strVal val="visible"/>
+                                      </p:to>
+                                    </p:set>
+                                  </p:childTnLst>
+                                </p:cTn>
+                              </p:par>
+                            </p:childTnLst>
+                          </p:cTn>
+                        </p:par>
+                      </p:childTnLst>
+                    </p:cTn>
+                  </p:par>
+                  <p:par>
+                    <p:cTn id="11" fill="hold">
+                      <p:stCondLst>
+                        <p:cond delay="indefinite"/>
+                      </p:stCondLst>
+                      <p:childTnLst>
+                        <p:par>
+                          <p:cTn id="12" fill="hold">
+                            <p:stCondLst>
+                              <p:cond delay="0"/>
+                            </p:stCondLst>
+                            <p:childTnLst>
+                              <p:par>
+                                <p:cTn id="13" presetID="1" presetClass="entr" presetSubtype="0" fill="hold" grpId="0" nodeType="clickEffect">
+                                  <p:stCondLst>
+                                    <p:cond delay="0"/>
+                                  </p:stCondLst>
+                                  <p:childTnLst>
+                                    <p:set>
+                                      <p:cBhvr>
+                                        <p:cTn id="14" dur="1" fill="hold">
+                                          <p:stCondLst>
+                                            <p:cond delay="0"/>
+                                          </p:stCondLst>
+                                        </p:cTn>
+                                        <p:tgtEl>
+                                          <p:spTgt spid="3">
+                                            <p:txEl>
+                                              <p:pRg st="3" end="3"/>
+                                            </p:txEl>
+                                          </p:spTgt>
+                                        </p:tgtEl>
+                                        <p:attrNameLst>
+                                          <p:attrName>style.visibility</p:attrName>
+                                        </p:attrNameLst>
+                                      </p:cBhvr>
+                                      <p:to>
+                                        <p:strVal val="visible"/>
+                                      </p:to>
+                                    </p:set>
+                                  </p:childTnLst>
+                                </p:cTn>
+                              </p:par>
+                            </p:childTnLst>
+                          </p:cTn>
+                        </p:par>
+                      </p:childTnLst>
+                    </p:cTn>
+                  </p:par>
+                  <p:par>
+                    <p:cTn id="15" fill="hold">
+                      <p:stCondLst>
+                        <p:cond delay="indefinite"/>
+                      </p:stCondLst>
+                      <p:childTnLst>
+                        <p:par>
+                          <p:cTn id="16" fill="hold">
+                            <p:stCondLst>
+                              <p:cond delay="0"/>
+                            </p:stCondLst>
+                            <p:childTnLst>
+                              <p:par>
+                                <p:cTn id="17" presetID="1" presetClass="entr" presetSubtype="0" fill="hold" grpId="0" nodeType="clickEffect">
+                                  <p:stCondLst>
+                                    <p:cond delay="0"/>
+                                  </p:stCondLst>
+                                  <p:childTnLst>
+                                    <p:set>
+                                      <p:cBhvr>
+                                        <p:cTn id="18" dur="1" fill="hold">
+                                          <p:stCondLst>
+                                            <p:cond delay="0"/>
+                                          </p:stCondLst>
+                                        </p:cTn>
+                                        <p:tgtEl>
+                                          <p:spTgt spid="3">
+                                            <p:txEl>
+                                              <p:pRg st="4" end="4"/>
+                                            </p:txEl>
+                                          </p:spTgt>
+                                        </p:tgtEl>
+                                        <p:attrNameLst>
+                                          <p:attrName>style.visibility</p:attrName>
+                                        </p:attrNameLst>
+                                      </p:cBhvr>
+                                      <p:to>
+                                        <p:strVal val="visible"/>
+                                      </p:to>
+                                    </p:set>
+                                  </p:childTnLst>
+                                </p:cTn>
+                              </p:par>
+                            </p:childTnLst>
+                          </p:cTn>
+                        </p:par>
+                      </p:childTnLst>
+                    </p:cTn>
+                  </p:par>
+                  <p:par>
+                    <p:cTn id="19" fill="hold">
+                      <p:stCondLst>
+                        <p:cond delay="indefinite"/>
+                      </p:stCondLst>
+                      <p:childTnLst>
+                        <p:par>
+                          <p:cTn id="20" fill="hold">
+                            <p:stCondLst>
+                              <p:cond delay="0"/>
+                            </p:stCondLst>
+                            <p:childTnLst>
+                              <p:par>
+                                <p:cTn id="21" presetID="1" presetClass="entr" presetSubtype="0" fill="hold" grpId="0" nodeType="clickEffect">
+                                  <p:stCondLst>
+                                    <p:cond delay="0"/>
+                                  </p:stCondLst>
+                                  <p:childTnLst>
+                                    <p:set>
+                                      <p:cBhvr>
+                                        <p:cTn id="22" dur="1" fill="hold">
+                                          <p:stCondLst>
+                                            <p:cond delay="0"/>
+                                          </p:stCondLst>
+                                        </p:cTn>
+                                        <p:tgtEl>
+                                          <p:spTgt spid="3">
+                                            <p:txEl>
+                                              <p:pRg st="5" end="5"/>
+                                            </p:txEl>
+                                          </p:spTgt>
+                                        </p:tgtEl>
+                                        <p:attrNameLst>
+                                          <p:attrName>style.visibility</p:attrName>
+                                        </p:attrNameLst>
+                                      </p:cBhvr>
+                                      <p:to>
+                                        <p:strVal val="visible"/>
+                                      </p:to>
+                                    </p:set>
+                                  </p:childTnLst>
+                                </p:cTn>
+                              </p:par>
+                            </p:childTnLst>
+                          </p:cTn>
+                        </p:par>
+                      </p:childTnLst>
+                    </p:cTn>
+                  </p:par>
+                  <p:par>
+                    <p:cTn id="23" fill="hold">
+                      <p:stCondLst>
+                        <p:cond delay="indefinite"/>
+                      </p:stCondLst>
+                      <p:childTnLst>
+                        <p:par>
+                          <p:cTn id="24" fill="hold">
+                            <p:stCondLst>
+                              <p:cond delay="0"/>
+                            </p:stCondLst>
+                            <p:childTnLst>
+                              <p:par>
+                                <p:cTn id="25" presetID="1" presetClass="entr" presetSubtype="0" fill="hold" nodeType="clickEffect">
+                                  <p:stCondLst>
+                                    <p:cond delay="0"/>
+                                  </p:stCondLst>
+                                  <p:childTnLst>
+                                    <p:set>
+                                      <p:cBhvr>
+                                        <p:cTn id="26" dur="1" fill="hold">
+                                          <p:stCondLst>
+                                            <p:cond delay="0"/>
+                                          </p:stCondLst>
+                                        </p:cTn>
+                                        <p:tgtEl>
+                                          <p:spTgt spid="5"/>
+                                        </p:tgtEl>
+                                        <p:attrNameLst>
+                                          <p:attrName>style.visibility</p:attrName>
+                                        </p:attrNameLst>
+                                      </p:cBhvr>
+                                      <p:to>
+                                        <p:strVal val="visible"/>
+                                      </p:to>
+                                    </p:set>
+                                  </p:childTnLst>
+                                </p:cTn>
+                              </p:par>
+                            </p:childTnLst>
+                          </p:cTn>
+                        </p:par>
+                      </p:childTnLst>
+                    </p:cTn>
+                  </p:par>
+                  <p:par>
+                    <p:cTn id="27" fill="hold">
+                      <p:stCondLst>
+                        <p:cond delay="indefinite"/>
+                      </p:stCondLst>
+                      <p:childTnLst>
+                        <p:par>
+                          <p:cTn id="28" fill="hold">
+                            <p:stCondLst>
+                              <p:cond delay="0"/>
+                            </p:stCondLst>
+                            <p:childTnLst>
+                              <p:par>
+                                <p:cTn id="29" presetID="1" presetClass="entr" presetSubtype="0" fill="hold" grpId="0" nodeType="clickEffect">
+                                  <p:stCondLst>
+                                    <p:cond delay="0"/>
+                                  </p:stCondLst>
+                                  <p:childTnLst>
+                                    <p:set>
+                                      <p:cBhvr>
+                                        <p:cTn id="30" dur="1" fill="hold">
+                                          <p:stCondLst>
+                                            <p:cond delay="0"/>
+                                          </p:stCondLst>
+                                        </p:cTn>
+                                        <p:tgtEl>
+                                          <p:spTgt spid="3">
+                                            <p:txEl>
+                                              <p:pRg st="6" end="6"/>
+                                            </p:txEl>
+                                          </p:spTgt>
+                                        </p:tgtEl>
+                                        <p:attrNameLst>
+                                          <p:attrName>style.visibility</p:attrName>
+                                        </p:attrNameLst>
+                                      </p:cBhvr>
+                                      <p:to>
+                                        <p:strVal val="visible"/>
+                                      </p:to>
+                                    </p:set>
+                                  </p:childTnLst>
+                                </p:cTn>
+                              </p:par>
+                            </p:childTnLst>
+                          </p:cTn>
+                        </p:par>
+                      </p:childTnLst>
+                    </p:cTn>
+                  </p:par>
+                </p:childTnLst>
+              </p:cTn>
+              <p:prevCondLst>
+                <p:cond evt="onPrev" delay="0">
+                  <p:tgtEl>
+                    <p:sldTgt/>
+                  </p:tgtEl>
+                </p:cond>
+              </p:prevCondLst>
+              <p:nextCondLst>
+                <p:cond evt="onNext" delay="0">
+                  <p:tgtEl>
+                    <p:sldTgt/>
+                  </p:tgtEl>
+                </p:cond>
+              </p:nextCondLst>
+            </p:seq>
+          </p:childTnLst>
+        </p:cTn>
+      </p:par>
+    </p:tnLst>
+    <p:bldLst>
+      <p:bldP spid="3" grpId="0" uiExpand="1" build="p"/>
+    </p:bldLst>
+  </p:timing>
+</p:sld>
+</file>
+
+<file path=ppt/slides/slide5.xml><?xml version="1.0" encoding="utf-8"?>
+<p:sld xmlns:a="http://schemas.openxmlformats.org/drawingml/2006/main" xmlns:r="http://schemas.openxmlformats.org/officeDocument/2006/relationships" xmlns:p="http://schemas.openxmlformats.org/presentationml/2006/main">
+  <p:cSld>
+    <p:spTree>
+      <p:nvGrpSpPr>
+        <p:cNvPr id="1" name=""/>
+        <p:cNvGrpSpPr/>
+        <p:nvPr/>
+      </p:nvGrpSpPr>
+      <p:grpSpPr>
+        <a:xfrm>
+          <a:off x="0" y="0"/>
+          <a:ext cx="0" cy="0"/>
+          <a:chOff x="0" y="0"/>
+          <a:chExt cx="0" cy="0"/>
+        </a:xfrm>
+      </p:grpSpPr>
+      <p:sp>
+        <p:nvSpPr>
+          <p:cNvPr id="2" name="Title 1">
+            <a:extLst>
+              <a:ext uri="{FF2B5EF4-FFF2-40B4-BE49-F238E27FC236}">
                 <a16:creationId xmlns:a16="http://schemas.microsoft.com/office/drawing/2014/main" id="{DA07567B-1302-4C38-B725-DA2F8BC97AF6}"/>
               </a:ext>
             </a:extLst>
@@ -6294,12 +7409,14 @@
         </p:nvSpPr>
         <p:spPr/>
         <p:txBody>
-          <a:bodyPr/>
+          <a:bodyPr>
+            <a:normAutofit/>
+          </a:bodyPr>
           <a:lstStyle/>
           <a:p>
             <a:r>
-              <a:rPr lang="en-US" dirty="0"/>
-              <a:t>Adding Java to the PATH </a:t>
+              <a:rPr lang="en-US" sz="3600" dirty="0"/>
+              <a:t>Adding Java to the PATH (if you used the first link)</a:t>
             </a:r>
           </a:p>
         </p:txBody>
@@ -6518,136 +7635,488 @@
   <p:clrMapOvr>
     <a:masterClrMapping/>
   </p:clrMapOvr>
-</p:sld>
-</file>
-
-<file path=ppt/slides/slide5.xml><?xml version="1.0" encoding="utf-8"?>
-<p:sld xmlns:a="http://schemas.openxmlformats.org/drawingml/2006/main" xmlns:r="http://schemas.openxmlformats.org/officeDocument/2006/relationships" xmlns:p="http://schemas.openxmlformats.org/presentationml/2006/main">
-  <p:cSld>
-    <p:spTree>
-      <p:nvGrpSpPr>
-        <p:cNvPr id="1" name=""/>
-        <p:cNvGrpSpPr/>
-        <p:nvPr/>
-      </p:nvGrpSpPr>
-      <p:grpSpPr>
-        <a:xfrm>
-          <a:off x="0" y="0"/>
-          <a:ext cx="0" cy="0"/>
-          <a:chOff x="0" y="0"/>
-          <a:chExt cx="0" cy="0"/>
-        </a:xfrm>
-      </p:grpSpPr>
-      <p:sp>
-        <p:nvSpPr>
-          <p:cNvPr id="2" name="Title 1">
-            <a:extLst>
-              <a:ext uri="{FF2B5EF4-FFF2-40B4-BE49-F238E27FC236}">
-                <a16:creationId xmlns:a16="http://schemas.microsoft.com/office/drawing/2014/main" id="{1117214F-2CBA-405B-B7E3-1FC9280DBF3F}"/>
-              </a:ext>
-            </a:extLst>
-          </p:cNvPr>
-          <p:cNvSpPr>
-            <a:spLocks noGrp="1"/>
-          </p:cNvSpPr>
-          <p:nvPr>
-            <p:ph type="title"/>
-          </p:nvPr>
-        </p:nvSpPr>
-        <p:spPr/>
-        <p:txBody>
-          <a:bodyPr/>
-          <a:lstStyle/>
-          <a:p>
-            <a:r>
-              <a:rPr lang="en-US" dirty="0"/>
-              <a:t>Running a Program</a:t>
-            </a:r>
-          </a:p>
-        </p:txBody>
-      </p:sp>
-      <p:sp>
-        <p:nvSpPr>
-          <p:cNvPr id="5" name="Content Placeholder 4">
-            <a:extLst>
-              <a:ext uri="{FF2B5EF4-FFF2-40B4-BE49-F238E27FC236}">
-                <a16:creationId xmlns:a16="http://schemas.microsoft.com/office/drawing/2014/main" id="{DB2B5B57-9072-4BB8-96A0-E4ED2FEFA789}"/>
-              </a:ext>
-            </a:extLst>
-          </p:cNvPr>
-          <p:cNvSpPr>
-            <a:spLocks noGrp="1"/>
-          </p:cNvSpPr>
-          <p:nvPr>
-            <p:ph idx="1"/>
-          </p:nvPr>
-        </p:nvSpPr>
-        <p:spPr/>
-        <p:txBody>
-          <a:bodyPr/>
-          <a:lstStyle/>
-          <a:p>
-            <a:r>
-              <a:rPr lang="en-US" dirty="0"/>
-              <a:t>Let’s use a simple program </a:t>
-            </a:r>
-            <a:r>
-              <a:rPr lang="en-US" b="1" dirty="0"/>
-              <a:t>Hello.java</a:t>
-            </a:r>
-          </a:p>
-          <a:p>
-            <a:r>
-              <a:rPr lang="en-US" dirty="0"/>
-              <a:t>Compile the program first, like so: </a:t>
-            </a:r>
-            <a:r>
-              <a:rPr lang="en-US" b="1" dirty="0" err="1"/>
-              <a:t>javac</a:t>
-            </a:r>
-            <a:r>
-              <a:rPr lang="en-US" b="1" dirty="0"/>
-              <a:t> Hello.java</a:t>
-            </a:r>
-          </a:p>
-          <a:p>
-            <a:pPr marL="0" indent="0">
-              <a:buNone/>
-            </a:pPr>
-            <a:r>
-              <a:rPr lang="en-US" dirty="0"/>
-              <a:t>This creates an executable file</a:t>
-            </a:r>
-          </a:p>
-          <a:p>
-            <a:r>
-              <a:rPr lang="en-US" dirty="0"/>
-              <a:t>Now we can run the program, like so: </a:t>
-            </a:r>
-            <a:r>
-              <a:rPr lang="en-US" b="1" dirty="0"/>
-              <a:t>java Hello</a:t>
-            </a:r>
-            <a:endParaRPr lang="en-US" dirty="0"/>
-          </a:p>
-          <a:p>
-            <a:pPr marL="0" indent="0">
-              <a:buNone/>
-            </a:pPr>
-            <a:endParaRPr lang="en-US" dirty="0"/>
-          </a:p>
-        </p:txBody>
-      </p:sp>
-    </p:spTree>
-    <p:extLst>
-      <p:ext uri="{BB962C8B-B14F-4D97-AF65-F5344CB8AC3E}">
-        <p14:creationId xmlns:p14="http://schemas.microsoft.com/office/powerpoint/2010/main" val="1471185745"/>
-      </p:ext>
-    </p:extLst>
-  </p:cSld>
-  <p:clrMapOvr>
-    <a:masterClrMapping/>
-  </p:clrMapOvr>
+  <mc:AlternateContent xmlns:mc="http://schemas.openxmlformats.org/markup-compatibility/2006">
+    <mc:Choice xmlns:p14="http://schemas.microsoft.com/office/powerpoint/2010/main" Requires="p14">
+      <p:transition spd="med" p14:dur="700">
+        <p:fade/>
+      </p:transition>
+    </mc:Choice>
+    <mc:Fallback>
+      <p:transition spd="med">
+        <p:fade/>
+      </p:transition>
+    </mc:Fallback>
+  </mc:AlternateContent>
+  <p:timing>
+    <p:tnLst>
+      <p:par>
+        <p:cTn id="1" dur="indefinite" restart="never" nodeType="tmRoot">
+          <p:childTnLst>
+            <p:seq concurrent="1" nextAc="seek">
+              <p:cTn id="2" dur="indefinite" nodeType="mainSeq">
+                <p:childTnLst>
+                  <p:par>
+                    <p:cTn id="3" fill="hold">
+                      <p:stCondLst>
+                        <p:cond delay="indefinite"/>
+                      </p:stCondLst>
+                      <p:childTnLst>
+                        <p:par>
+                          <p:cTn id="4" fill="hold">
+                            <p:stCondLst>
+                              <p:cond delay="0"/>
+                            </p:stCondLst>
+                            <p:childTnLst>
+                              <p:par>
+                                <p:cTn id="5" presetID="1" presetClass="entr" presetSubtype="0" fill="hold" grpId="0" nodeType="clickEffect">
+                                  <p:stCondLst>
+                                    <p:cond delay="0"/>
+                                  </p:stCondLst>
+                                  <p:childTnLst>
+                                    <p:set>
+                                      <p:cBhvr>
+                                        <p:cTn id="6" dur="1" fill="hold">
+                                          <p:stCondLst>
+                                            <p:cond delay="0"/>
+                                          </p:stCondLst>
+                                        </p:cTn>
+                                        <p:tgtEl>
+                                          <p:spTgt spid="3">
+                                            <p:txEl>
+                                              <p:pRg st="0" end="0"/>
+                                            </p:txEl>
+                                          </p:spTgt>
+                                        </p:tgtEl>
+                                        <p:attrNameLst>
+                                          <p:attrName>style.visibility</p:attrName>
+                                        </p:attrNameLst>
+                                      </p:cBhvr>
+                                      <p:to>
+                                        <p:strVal val="visible"/>
+                                      </p:to>
+                                    </p:set>
+                                  </p:childTnLst>
+                                </p:cTn>
+                              </p:par>
+                            </p:childTnLst>
+                          </p:cTn>
+                        </p:par>
+                      </p:childTnLst>
+                    </p:cTn>
+                  </p:par>
+                  <p:par>
+                    <p:cTn id="7" fill="hold">
+                      <p:stCondLst>
+                        <p:cond delay="indefinite"/>
+                      </p:stCondLst>
+                      <p:childTnLst>
+                        <p:par>
+                          <p:cTn id="8" fill="hold">
+                            <p:stCondLst>
+                              <p:cond delay="0"/>
+                            </p:stCondLst>
+                            <p:childTnLst>
+                              <p:par>
+                                <p:cTn id="9" presetID="1" presetClass="entr" presetSubtype="0" fill="hold" grpId="0" nodeType="clickEffect">
+                                  <p:stCondLst>
+                                    <p:cond delay="0"/>
+                                  </p:stCondLst>
+                                  <p:childTnLst>
+                                    <p:set>
+                                      <p:cBhvr>
+                                        <p:cTn id="10" dur="1" fill="hold">
+                                          <p:stCondLst>
+                                            <p:cond delay="0"/>
+                                          </p:stCondLst>
+                                        </p:cTn>
+                                        <p:tgtEl>
+                                          <p:spTgt spid="3">
+                                            <p:txEl>
+                                              <p:pRg st="1" end="1"/>
+                                            </p:txEl>
+                                          </p:spTgt>
+                                        </p:tgtEl>
+                                        <p:attrNameLst>
+                                          <p:attrName>style.visibility</p:attrName>
+                                        </p:attrNameLst>
+                                      </p:cBhvr>
+                                      <p:to>
+                                        <p:strVal val="visible"/>
+                                      </p:to>
+                                    </p:set>
+                                  </p:childTnLst>
+                                </p:cTn>
+                              </p:par>
+                            </p:childTnLst>
+                          </p:cTn>
+                        </p:par>
+                      </p:childTnLst>
+                    </p:cTn>
+                  </p:par>
+                  <p:par>
+                    <p:cTn id="11" fill="hold">
+                      <p:stCondLst>
+                        <p:cond delay="indefinite"/>
+                      </p:stCondLst>
+                      <p:childTnLst>
+                        <p:par>
+                          <p:cTn id="12" fill="hold">
+                            <p:stCondLst>
+                              <p:cond delay="0"/>
+                            </p:stCondLst>
+                            <p:childTnLst>
+                              <p:par>
+                                <p:cTn id="13" presetID="1" presetClass="entr" presetSubtype="0" fill="hold" grpId="0" nodeType="clickEffect">
+                                  <p:stCondLst>
+                                    <p:cond delay="0"/>
+                                  </p:stCondLst>
+                                  <p:childTnLst>
+                                    <p:set>
+                                      <p:cBhvr>
+                                        <p:cTn id="14" dur="1" fill="hold">
+                                          <p:stCondLst>
+                                            <p:cond delay="0"/>
+                                          </p:stCondLst>
+                                        </p:cTn>
+                                        <p:tgtEl>
+                                          <p:spTgt spid="3">
+                                            <p:txEl>
+                                              <p:pRg st="2" end="2"/>
+                                            </p:txEl>
+                                          </p:spTgt>
+                                        </p:tgtEl>
+                                        <p:attrNameLst>
+                                          <p:attrName>style.visibility</p:attrName>
+                                        </p:attrNameLst>
+                                      </p:cBhvr>
+                                      <p:to>
+                                        <p:strVal val="visible"/>
+                                      </p:to>
+                                    </p:set>
+                                  </p:childTnLst>
+                                </p:cTn>
+                              </p:par>
+                            </p:childTnLst>
+                          </p:cTn>
+                        </p:par>
+                      </p:childTnLst>
+                    </p:cTn>
+                  </p:par>
+                  <p:par>
+                    <p:cTn id="15" fill="hold">
+                      <p:stCondLst>
+                        <p:cond delay="indefinite"/>
+                      </p:stCondLst>
+                      <p:childTnLst>
+                        <p:par>
+                          <p:cTn id="16" fill="hold">
+                            <p:stCondLst>
+                              <p:cond delay="0"/>
+                            </p:stCondLst>
+                            <p:childTnLst>
+                              <p:par>
+                                <p:cTn id="17" presetID="1" presetClass="entr" presetSubtype="0" fill="hold" grpId="0" nodeType="clickEffect">
+                                  <p:stCondLst>
+                                    <p:cond delay="0"/>
+                                  </p:stCondLst>
+                                  <p:childTnLst>
+                                    <p:set>
+                                      <p:cBhvr>
+                                        <p:cTn id="18" dur="1" fill="hold">
+                                          <p:stCondLst>
+                                            <p:cond delay="0"/>
+                                          </p:stCondLst>
+                                        </p:cTn>
+                                        <p:tgtEl>
+                                          <p:spTgt spid="3">
+                                            <p:txEl>
+                                              <p:pRg st="3" end="3"/>
+                                            </p:txEl>
+                                          </p:spTgt>
+                                        </p:tgtEl>
+                                        <p:attrNameLst>
+                                          <p:attrName>style.visibility</p:attrName>
+                                        </p:attrNameLst>
+                                      </p:cBhvr>
+                                      <p:to>
+                                        <p:strVal val="visible"/>
+                                      </p:to>
+                                    </p:set>
+                                  </p:childTnLst>
+                                </p:cTn>
+                              </p:par>
+                            </p:childTnLst>
+                          </p:cTn>
+                        </p:par>
+                      </p:childTnLst>
+                    </p:cTn>
+                  </p:par>
+                  <p:par>
+                    <p:cTn id="19" fill="hold">
+                      <p:stCondLst>
+                        <p:cond delay="indefinite"/>
+                      </p:stCondLst>
+                      <p:childTnLst>
+                        <p:par>
+                          <p:cTn id="20" fill="hold">
+                            <p:stCondLst>
+                              <p:cond delay="0"/>
+                            </p:stCondLst>
+                            <p:childTnLst>
+                              <p:par>
+                                <p:cTn id="21" presetID="1" presetClass="entr" presetSubtype="0" fill="hold" grpId="0" nodeType="clickEffect">
+                                  <p:stCondLst>
+                                    <p:cond delay="0"/>
+                                  </p:stCondLst>
+                                  <p:childTnLst>
+                                    <p:set>
+                                      <p:cBhvr>
+                                        <p:cTn id="22" dur="1" fill="hold">
+                                          <p:stCondLst>
+                                            <p:cond delay="0"/>
+                                          </p:stCondLst>
+                                        </p:cTn>
+                                        <p:tgtEl>
+                                          <p:spTgt spid="3">
+                                            <p:txEl>
+                                              <p:pRg st="4" end="4"/>
+                                            </p:txEl>
+                                          </p:spTgt>
+                                        </p:tgtEl>
+                                        <p:attrNameLst>
+                                          <p:attrName>style.visibility</p:attrName>
+                                        </p:attrNameLst>
+                                      </p:cBhvr>
+                                      <p:to>
+                                        <p:strVal val="visible"/>
+                                      </p:to>
+                                    </p:set>
+                                  </p:childTnLst>
+                                </p:cTn>
+                              </p:par>
+                            </p:childTnLst>
+                          </p:cTn>
+                        </p:par>
+                      </p:childTnLst>
+                    </p:cTn>
+                  </p:par>
+                  <p:par>
+                    <p:cTn id="23" fill="hold">
+                      <p:stCondLst>
+                        <p:cond delay="indefinite"/>
+                      </p:stCondLst>
+                      <p:childTnLst>
+                        <p:par>
+                          <p:cTn id="24" fill="hold">
+                            <p:stCondLst>
+                              <p:cond delay="0"/>
+                            </p:stCondLst>
+                            <p:childTnLst>
+                              <p:par>
+                                <p:cTn id="25" presetID="1" presetClass="entr" presetSubtype="0" fill="hold" grpId="0" nodeType="clickEffect">
+                                  <p:stCondLst>
+                                    <p:cond delay="0"/>
+                                  </p:stCondLst>
+                                  <p:childTnLst>
+                                    <p:set>
+                                      <p:cBhvr>
+                                        <p:cTn id="26" dur="1" fill="hold">
+                                          <p:stCondLst>
+                                            <p:cond delay="0"/>
+                                          </p:stCondLst>
+                                        </p:cTn>
+                                        <p:tgtEl>
+                                          <p:spTgt spid="3">
+                                            <p:txEl>
+                                              <p:pRg st="5" end="5"/>
+                                            </p:txEl>
+                                          </p:spTgt>
+                                        </p:tgtEl>
+                                        <p:attrNameLst>
+                                          <p:attrName>style.visibility</p:attrName>
+                                        </p:attrNameLst>
+                                      </p:cBhvr>
+                                      <p:to>
+                                        <p:strVal val="visible"/>
+                                      </p:to>
+                                    </p:set>
+                                  </p:childTnLst>
+                                </p:cTn>
+                              </p:par>
+                            </p:childTnLst>
+                          </p:cTn>
+                        </p:par>
+                      </p:childTnLst>
+                    </p:cTn>
+                  </p:par>
+                  <p:par>
+                    <p:cTn id="27" fill="hold">
+                      <p:stCondLst>
+                        <p:cond delay="indefinite"/>
+                      </p:stCondLst>
+                      <p:childTnLst>
+                        <p:par>
+                          <p:cTn id="28" fill="hold">
+                            <p:stCondLst>
+                              <p:cond delay="0"/>
+                            </p:stCondLst>
+                            <p:childTnLst>
+                              <p:par>
+                                <p:cTn id="29" presetID="1" presetClass="entr" presetSubtype="0" fill="hold" grpId="0" nodeType="clickEffect">
+                                  <p:stCondLst>
+                                    <p:cond delay="0"/>
+                                  </p:stCondLst>
+                                  <p:childTnLst>
+                                    <p:set>
+                                      <p:cBhvr>
+                                        <p:cTn id="30" dur="1" fill="hold">
+                                          <p:stCondLst>
+                                            <p:cond delay="0"/>
+                                          </p:stCondLst>
+                                        </p:cTn>
+                                        <p:tgtEl>
+                                          <p:spTgt spid="3">
+                                            <p:txEl>
+                                              <p:pRg st="6" end="6"/>
+                                            </p:txEl>
+                                          </p:spTgt>
+                                        </p:tgtEl>
+                                        <p:attrNameLst>
+                                          <p:attrName>style.visibility</p:attrName>
+                                        </p:attrNameLst>
+                                      </p:cBhvr>
+                                      <p:to>
+                                        <p:strVal val="visible"/>
+                                      </p:to>
+                                    </p:set>
+                                  </p:childTnLst>
+                                </p:cTn>
+                              </p:par>
+                            </p:childTnLst>
+                          </p:cTn>
+                        </p:par>
+                      </p:childTnLst>
+                    </p:cTn>
+                  </p:par>
+                  <p:par>
+                    <p:cTn id="31" fill="hold">
+                      <p:stCondLst>
+                        <p:cond delay="indefinite"/>
+                      </p:stCondLst>
+                      <p:childTnLst>
+                        <p:par>
+                          <p:cTn id="32" fill="hold">
+                            <p:stCondLst>
+                              <p:cond delay="0"/>
+                            </p:stCondLst>
+                            <p:childTnLst>
+                              <p:par>
+                                <p:cTn id="33" presetID="1" presetClass="entr" presetSubtype="0" fill="hold" grpId="0" nodeType="clickEffect">
+                                  <p:stCondLst>
+                                    <p:cond delay="0"/>
+                                  </p:stCondLst>
+                                  <p:childTnLst>
+                                    <p:set>
+                                      <p:cBhvr>
+                                        <p:cTn id="34" dur="1" fill="hold">
+                                          <p:stCondLst>
+                                            <p:cond delay="0"/>
+                                          </p:stCondLst>
+                                        </p:cTn>
+                                        <p:tgtEl>
+                                          <p:spTgt spid="3">
+                                            <p:txEl>
+                                              <p:pRg st="7" end="7"/>
+                                            </p:txEl>
+                                          </p:spTgt>
+                                        </p:tgtEl>
+                                        <p:attrNameLst>
+                                          <p:attrName>style.visibility</p:attrName>
+                                        </p:attrNameLst>
+                                      </p:cBhvr>
+                                      <p:to>
+                                        <p:strVal val="visible"/>
+                                      </p:to>
+                                    </p:set>
+                                  </p:childTnLst>
+                                </p:cTn>
+                              </p:par>
+                            </p:childTnLst>
+                          </p:cTn>
+                        </p:par>
+                      </p:childTnLst>
+                    </p:cTn>
+                  </p:par>
+                  <p:par>
+                    <p:cTn id="35" fill="hold">
+                      <p:stCondLst>
+                        <p:cond delay="indefinite"/>
+                      </p:stCondLst>
+                      <p:childTnLst>
+                        <p:par>
+                          <p:cTn id="36" fill="hold">
+                            <p:stCondLst>
+                              <p:cond delay="0"/>
+                            </p:stCondLst>
+                            <p:childTnLst>
+                              <p:par>
+                                <p:cTn id="37" presetID="1" presetClass="entr" presetSubtype="0" fill="hold" nodeType="clickEffect">
+                                  <p:stCondLst>
+                                    <p:cond delay="0"/>
+                                  </p:stCondLst>
+                                  <p:childTnLst>
+                                    <p:set>
+                                      <p:cBhvr>
+                                        <p:cTn id="38" dur="1" fill="hold">
+                                          <p:stCondLst>
+                                            <p:cond delay="0"/>
+                                          </p:stCondLst>
+                                        </p:cTn>
+                                        <p:tgtEl>
+                                          <p:spTgt spid="5"/>
+                                        </p:tgtEl>
+                                        <p:attrNameLst>
+                                          <p:attrName>style.visibility</p:attrName>
+                                        </p:attrNameLst>
+                                      </p:cBhvr>
+                                      <p:to>
+                                        <p:strVal val="visible"/>
+                                      </p:to>
+                                    </p:set>
+                                  </p:childTnLst>
+                                </p:cTn>
+                              </p:par>
+                            </p:childTnLst>
+                          </p:cTn>
+                        </p:par>
+                      </p:childTnLst>
+                    </p:cTn>
+                  </p:par>
+                </p:childTnLst>
+              </p:cTn>
+              <p:prevCondLst>
+                <p:cond evt="onPrev" delay="0">
+                  <p:tgtEl>
+                    <p:sldTgt/>
+                  </p:tgtEl>
+                </p:cond>
+              </p:prevCondLst>
+              <p:nextCondLst>
+                <p:cond evt="onNext" delay="0">
+                  <p:tgtEl>
+                    <p:sldTgt/>
+                  </p:tgtEl>
+                </p:cond>
+              </p:nextCondLst>
+            </p:seq>
+          </p:childTnLst>
+        </p:cTn>
+      </p:par>
+    </p:tnLst>
+    <p:bldLst>
+      <p:bldP spid="3" grpId="0" uiExpand="1" build="p"/>
+    </p:bldLst>
+  </p:timing>
 </p:sld>
 </file>
 
@@ -6673,6 +8142,377 @@
           <p:cNvPr id="2" name="Title 1">
             <a:extLst>
               <a:ext uri="{FF2B5EF4-FFF2-40B4-BE49-F238E27FC236}">
+                <a16:creationId xmlns:a16="http://schemas.microsoft.com/office/drawing/2014/main" id="{1117214F-2CBA-405B-B7E3-1FC9280DBF3F}"/>
+              </a:ext>
+            </a:extLst>
+          </p:cNvPr>
+          <p:cNvSpPr>
+            <a:spLocks noGrp="1"/>
+          </p:cNvSpPr>
+          <p:nvPr>
+            <p:ph type="title"/>
+          </p:nvPr>
+        </p:nvSpPr>
+        <p:spPr/>
+        <p:txBody>
+          <a:bodyPr/>
+          <a:lstStyle/>
+          <a:p>
+            <a:r>
+              <a:rPr lang="en-US" dirty="0"/>
+              <a:t>Running a Program</a:t>
+            </a:r>
+          </a:p>
+        </p:txBody>
+      </p:sp>
+      <p:sp>
+        <p:nvSpPr>
+          <p:cNvPr id="5" name="Content Placeholder 4">
+            <a:extLst>
+              <a:ext uri="{FF2B5EF4-FFF2-40B4-BE49-F238E27FC236}">
+                <a16:creationId xmlns:a16="http://schemas.microsoft.com/office/drawing/2014/main" id="{DB2B5B57-9072-4BB8-96A0-E4ED2FEFA789}"/>
+              </a:ext>
+            </a:extLst>
+          </p:cNvPr>
+          <p:cNvSpPr>
+            <a:spLocks noGrp="1"/>
+          </p:cNvSpPr>
+          <p:nvPr>
+            <p:ph idx="1"/>
+          </p:nvPr>
+        </p:nvSpPr>
+        <p:spPr/>
+        <p:txBody>
+          <a:bodyPr/>
+          <a:lstStyle/>
+          <a:p>
+            <a:r>
+              <a:rPr lang="en-US" dirty="0"/>
+              <a:t>Let’s use a simple program </a:t>
+            </a:r>
+            <a:r>
+              <a:rPr lang="en-US" b="1" dirty="0"/>
+              <a:t>Hello.java</a:t>
+            </a:r>
+          </a:p>
+          <a:p>
+            <a:r>
+              <a:rPr lang="en-US" dirty="0"/>
+              <a:t>Compile the program first, like so: </a:t>
+            </a:r>
+            <a:r>
+              <a:rPr lang="en-US" b="1" dirty="0" err="1"/>
+              <a:t>javac</a:t>
+            </a:r>
+            <a:r>
+              <a:rPr lang="en-US" b="1" dirty="0"/>
+              <a:t> Hello.java</a:t>
+            </a:r>
+          </a:p>
+          <a:p>
+            <a:pPr marL="0" indent="0">
+              <a:buNone/>
+            </a:pPr>
+            <a:r>
+              <a:rPr lang="en-US" dirty="0"/>
+              <a:t>This creates an executable file</a:t>
+            </a:r>
+          </a:p>
+          <a:p>
+            <a:r>
+              <a:rPr lang="en-US" dirty="0"/>
+              <a:t>Now we can run the program, like so: </a:t>
+            </a:r>
+            <a:r>
+              <a:rPr lang="en-US" b="1" dirty="0"/>
+              <a:t>java Hello</a:t>
+            </a:r>
+            <a:endParaRPr lang="en-US" dirty="0"/>
+          </a:p>
+          <a:p>
+            <a:pPr marL="0" indent="0">
+              <a:buNone/>
+            </a:pPr>
+            <a:endParaRPr lang="en-US" dirty="0"/>
+          </a:p>
+        </p:txBody>
+      </p:sp>
+    </p:spTree>
+    <p:extLst>
+      <p:ext uri="{BB962C8B-B14F-4D97-AF65-F5344CB8AC3E}">
+        <p14:creationId xmlns:p14="http://schemas.microsoft.com/office/powerpoint/2010/main" val="1471185745"/>
+      </p:ext>
+    </p:extLst>
+  </p:cSld>
+  <p:clrMapOvr>
+    <a:masterClrMapping/>
+  </p:clrMapOvr>
+  <mc:AlternateContent xmlns:mc="http://schemas.openxmlformats.org/markup-compatibility/2006">
+    <mc:Choice xmlns:p14="http://schemas.microsoft.com/office/powerpoint/2010/main" Requires="p14">
+      <p:transition spd="med" p14:dur="700">
+        <p:fade/>
+      </p:transition>
+    </mc:Choice>
+    <mc:Fallback>
+      <p:transition spd="med">
+        <p:fade/>
+      </p:transition>
+    </mc:Fallback>
+  </mc:AlternateContent>
+  <p:timing>
+    <p:tnLst>
+      <p:par>
+        <p:cTn id="1" dur="indefinite" restart="never" nodeType="tmRoot">
+          <p:childTnLst>
+            <p:seq concurrent="1" nextAc="seek">
+              <p:cTn id="2" dur="indefinite" nodeType="mainSeq">
+                <p:childTnLst>
+                  <p:par>
+                    <p:cTn id="3" fill="hold">
+                      <p:stCondLst>
+                        <p:cond delay="indefinite"/>
+                      </p:stCondLst>
+                      <p:childTnLst>
+                        <p:par>
+                          <p:cTn id="4" fill="hold">
+                            <p:stCondLst>
+                              <p:cond delay="0"/>
+                            </p:stCondLst>
+                            <p:childTnLst>
+                              <p:par>
+                                <p:cTn id="5" presetID="1" presetClass="entr" presetSubtype="0" fill="hold" grpId="0" nodeType="clickEffect">
+                                  <p:stCondLst>
+                                    <p:cond delay="0"/>
+                                  </p:stCondLst>
+                                  <p:childTnLst>
+                                    <p:set>
+                                      <p:cBhvr>
+                                        <p:cTn id="6" dur="1" fill="hold">
+                                          <p:stCondLst>
+                                            <p:cond delay="0"/>
+                                          </p:stCondLst>
+                                        </p:cTn>
+                                        <p:tgtEl>
+                                          <p:spTgt spid="5">
+                                            <p:txEl>
+                                              <p:pRg st="0" end="0"/>
+                                            </p:txEl>
+                                          </p:spTgt>
+                                        </p:tgtEl>
+                                        <p:attrNameLst>
+                                          <p:attrName>style.visibility</p:attrName>
+                                        </p:attrNameLst>
+                                      </p:cBhvr>
+                                      <p:to>
+                                        <p:strVal val="visible"/>
+                                      </p:to>
+                                    </p:set>
+                                  </p:childTnLst>
+                                </p:cTn>
+                              </p:par>
+                            </p:childTnLst>
+                          </p:cTn>
+                        </p:par>
+                      </p:childTnLst>
+                    </p:cTn>
+                  </p:par>
+                  <p:par>
+                    <p:cTn id="7" fill="hold">
+                      <p:stCondLst>
+                        <p:cond delay="indefinite"/>
+                      </p:stCondLst>
+                      <p:childTnLst>
+                        <p:par>
+                          <p:cTn id="8" fill="hold">
+                            <p:stCondLst>
+                              <p:cond delay="0"/>
+                            </p:stCondLst>
+                            <p:childTnLst>
+                              <p:par>
+                                <p:cTn id="9" presetID="1" presetClass="entr" presetSubtype="0" fill="hold" grpId="0" nodeType="clickEffect">
+                                  <p:stCondLst>
+                                    <p:cond delay="0"/>
+                                  </p:stCondLst>
+                                  <p:childTnLst>
+                                    <p:set>
+                                      <p:cBhvr>
+                                        <p:cTn id="10" dur="1" fill="hold">
+                                          <p:stCondLst>
+                                            <p:cond delay="0"/>
+                                          </p:stCondLst>
+                                        </p:cTn>
+                                        <p:tgtEl>
+                                          <p:spTgt spid="5">
+                                            <p:txEl>
+                                              <p:pRg st="1" end="1"/>
+                                            </p:txEl>
+                                          </p:spTgt>
+                                        </p:tgtEl>
+                                        <p:attrNameLst>
+                                          <p:attrName>style.visibility</p:attrName>
+                                        </p:attrNameLst>
+                                      </p:cBhvr>
+                                      <p:to>
+                                        <p:strVal val="visible"/>
+                                      </p:to>
+                                    </p:set>
+                                  </p:childTnLst>
+                                </p:cTn>
+                              </p:par>
+                            </p:childTnLst>
+                          </p:cTn>
+                        </p:par>
+                      </p:childTnLst>
+                    </p:cTn>
+                  </p:par>
+                  <p:par>
+                    <p:cTn id="11" fill="hold">
+                      <p:stCondLst>
+                        <p:cond delay="indefinite"/>
+                      </p:stCondLst>
+                      <p:childTnLst>
+                        <p:par>
+                          <p:cTn id="12" fill="hold">
+                            <p:stCondLst>
+                              <p:cond delay="0"/>
+                            </p:stCondLst>
+                            <p:childTnLst>
+                              <p:par>
+                                <p:cTn id="13" presetID="1" presetClass="entr" presetSubtype="0" fill="hold" grpId="0" nodeType="clickEffect">
+                                  <p:stCondLst>
+                                    <p:cond delay="0"/>
+                                  </p:stCondLst>
+                                  <p:childTnLst>
+                                    <p:set>
+                                      <p:cBhvr>
+                                        <p:cTn id="14" dur="1" fill="hold">
+                                          <p:stCondLst>
+                                            <p:cond delay="0"/>
+                                          </p:stCondLst>
+                                        </p:cTn>
+                                        <p:tgtEl>
+                                          <p:spTgt spid="5">
+                                            <p:txEl>
+                                              <p:pRg st="2" end="2"/>
+                                            </p:txEl>
+                                          </p:spTgt>
+                                        </p:tgtEl>
+                                        <p:attrNameLst>
+                                          <p:attrName>style.visibility</p:attrName>
+                                        </p:attrNameLst>
+                                      </p:cBhvr>
+                                      <p:to>
+                                        <p:strVal val="visible"/>
+                                      </p:to>
+                                    </p:set>
+                                  </p:childTnLst>
+                                </p:cTn>
+                              </p:par>
+                            </p:childTnLst>
+                          </p:cTn>
+                        </p:par>
+                      </p:childTnLst>
+                    </p:cTn>
+                  </p:par>
+                  <p:par>
+                    <p:cTn id="15" fill="hold">
+                      <p:stCondLst>
+                        <p:cond delay="indefinite"/>
+                      </p:stCondLst>
+                      <p:childTnLst>
+                        <p:par>
+                          <p:cTn id="16" fill="hold">
+                            <p:stCondLst>
+                              <p:cond delay="0"/>
+                            </p:stCondLst>
+                            <p:childTnLst>
+                              <p:par>
+                                <p:cTn id="17" presetID="1" presetClass="entr" presetSubtype="0" fill="hold" grpId="0" nodeType="clickEffect">
+                                  <p:stCondLst>
+                                    <p:cond delay="0"/>
+                                  </p:stCondLst>
+                                  <p:childTnLst>
+                                    <p:set>
+                                      <p:cBhvr>
+                                        <p:cTn id="18" dur="1" fill="hold">
+                                          <p:stCondLst>
+                                            <p:cond delay="0"/>
+                                          </p:stCondLst>
+                                        </p:cTn>
+                                        <p:tgtEl>
+                                          <p:spTgt spid="5">
+                                            <p:txEl>
+                                              <p:pRg st="3" end="3"/>
+                                            </p:txEl>
+                                          </p:spTgt>
+                                        </p:tgtEl>
+                                        <p:attrNameLst>
+                                          <p:attrName>style.visibility</p:attrName>
+                                        </p:attrNameLst>
+                                      </p:cBhvr>
+                                      <p:to>
+                                        <p:strVal val="visible"/>
+                                      </p:to>
+                                    </p:set>
+                                  </p:childTnLst>
+                                </p:cTn>
+                              </p:par>
+                            </p:childTnLst>
+                          </p:cTn>
+                        </p:par>
+                      </p:childTnLst>
+                    </p:cTn>
+                  </p:par>
+                </p:childTnLst>
+              </p:cTn>
+              <p:prevCondLst>
+                <p:cond evt="onPrev" delay="0">
+                  <p:tgtEl>
+                    <p:sldTgt/>
+                  </p:tgtEl>
+                </p:cond>
+              </p:prevCondLst>
+              <p:nextCondLst>
+                <p:cond evt="onNext" delay="0">
+                  <p:tgtEl>
+                    <p:sldTgt/>
+                  </p:tgtEl>
+                </p:cond>
+              </p:nextCondLst>
+            </p:seq>
+          </p:childTnLst>
+        </p:cTn>
+      </p:par>
+    </p:tnLst>
+    <p:bldLst>
+      <p:bldP spid="5" grpId="0" build="p"/>
+    </p:bldLst>
+  </p:timing>
+</p:sld>
+</file>
+
+<file path=ppt/slides/slide7.xml><?xml version="1.0" encoding="utf-8"?>
+<p:sld xmlns:a="http://schemas.openxmlformats.org/drawingml/2006/main" xmlns:r="http://schemas.openxmlformats.org/officeDocument/2006/relationships" xmlns:p="http://schemas.openxmlformats.org/presentationml/2006/main">
+  <p:cSld>
+    <p:spTree>
+      <p:nvGrpSpPr>
+        <p:cNvPr id="1" name=""/>
+        <p:cNvGrpSpPr/>
+        <p:nvPr/>
+      </p:nvGrpSpPr>
+      <p:grpSpPr>
+        <a:xfrm>
+          <a:off x="0" y="0"/>
+          <a:ext cx="0" cy="0"/>
+          <a:chOff x="0" y="0"/>
+          <a:chExt cx="0" cy="0"/>
+        </a:xfrm>
+      </p:grpSpPr>
+      <p:sp>
+        <p:nvSpPr>
+          <p:cNvPr id="2" name="Title 1">
+            <a:extLst>
+              <a:ext uri="{FF2B5EF4-FFF2-40B4-BE49-F238E27FC236}">
                 <a16:creationId xmlns:a16="http://schemas.microsoft.com/office/drawing/2014/main" id="{80E1E491-37B1-4190-896D-7746B2727580}"/>
               </a:ext>
             </a:extLst>
@@ -6778,6 +8618,247 @@
   <p:clrMapOvr>
     <a:masterClrMapping/>
   </p:clrMapOvr>
+  <mc:AlternateContent xmlns:mc="http://schemas.openxmlformats.org/markup-compatibility/2006">
+    <mc:Choice xmlns:p14="http://schemas.microsoft.com/office/powerpoint/2010/main" Requires="p14">
+      <p:transition spd="med" p14:dur="700">
+        <p:fade/>
+      </p:transition>
+    </mc:Choice>
+    <mc:Fallback>
+      <p:transition spd="med">
+        <p:fade/>
+      </p:transition>
+    </mc:Fallback>
+  </mc:AlternateContent>
+  <p:timing>
+    <p:tnLst>
+      <p:par>
+        <p:cTn id="1" dur="indefinite" restart="never" nodeType="tmRoot">
+          <p:childTnLst>
+            <p:seq concurrent="1" nextAc="seek">
+              <p:cTn id="2" dur="indefinite" nodeType="mainSeq">
+                <p:childTnLst>
+                  <p:par>
+                    <p:cTn id="3" fill="hold">
+                      <p:stCondLst>
+                        <p:cond delay="indefinite"/>
+                      </p:stCondLst>
+                      <p:childTnLst>
+                        <p:par>
+                          <p:cTn id="4" fill="hold">
+                            <p:stCondLst>
+                              <p:cond delay="0"/>
+                            </p:stCondLst>
+                            <p:childTnLst>
+                              <p:par>
+                                <p:cTn id="5" presetID="1" presetClass="entr" presetSubtype="0" fill="hold" grpId="0" nodeType="clickEffect">
+                                  <p:stCondLst>
+                                    <p:cond delay="0"/>
+                                  </p:stCondLst>
+                                  <p:childTnLst>
+                                    <p:set>
+                                      <p:cBhvr>
+                                        <p:cTn id="6" dur="1" fill="hold">
+                                          <p:stCondLst>
+                                            <p:cond delay="0"/>
+                                          </p:stCondLst>
+                                        </p:cTn>
+                                        <p:tgtEl>
+                                          <p:spTgt spid="3">
+                                            <p:txEl>
+                                              <p:pRg st="0" end="0"/>
+                                            </p:txEl>
+                                          </p:spTgt>
+                                        </p:tgtEl>
+                                        <p:attrNameLst>
+                                          <p:attrName>style.visibility</p:attrName>
+                                        </p:attrNameLst>
+                                      </p:cBhvr>
+                                      <p:to>
+                                        <p:strVal val="visible"/>
+                                      </p:to>
+                                    </p:set>
+                                  </p:childTnLst>
+                                </p:cTn>
+                              </p:par>
+                            </p:childTnLst>
+                          </p:cTn>
+                        </p:par>
+                      </p:childTnLst>
+                    </p:cTn>
+                  </p:par>
+                  <p:par>
+                    <p:cTn id="7" fill="hold">
+                      <p:stCondLst>
+                        <p:cond delay="indefinite"/>
+                      </p:stCondLst>
+                      <p:childTnLst>
+                        <p:par>
+                          <p:cTn id="8" fill="hold">
+                            <p:stCondLst>
+                              <p:cond delay="0"/>
+                            </p:stCondLst>
+                            <p:childTnLst>
+                              <p:par>
+                                <p:cTn id="9" presetID="1" presetClass="entr" presetSubtype="0" fill="hold" grpId="0" nodeType="clickEffect">
+                                  <p:stCondLst>
+                                    <p:cond delay="0"/>
+                                  </p:stCondLst>
+                                  <p:childTnLst>
+                                    <p:set>
+                                      <p:cBhvr>
+                                        <p:cTn id="10" dur="1" fill="hold">
+                                          <p:stCondLst>
+                                            <p:cond delay="0"/>
+                                          </p:stCondLst>
+                                        </p:cTn>
+                                        <p:tgtEl>
+                                          <p:spTgt spid="3">
+                                            <p:txEl>
+                                              <p:pRg st="1" end="1"/>
+                                            </p:txEl>
+                                          </p:spTgt>
+                                        </p:tgtEl>
+                                        <p:attrNameLst>
+                                          <p:attrName>style.visibility</p:attrName>
+                                        </p:attrNameLst>
+                                      </p:cBhvr>
+                                      <p:to>
+                                        <p:strVal val="visible"/>
+                                      </p:to>
+                                    </p:set>
+                                  </p:childTnLst>
+                                </p:cTn>
+                              </p:par>
+                            </p:childTnLst>
+                          </p:cTn>
+                        </p:par>
+                      </p:childTnLst>
+                    </p:cTn>
+                  </p:par>
+                  <p:par>
+                    <p:cTn id="11" fill="hold">
+                      <p:stCondLst>
+                        <p:cond delay="indefinite"/>
+                      </p:stCondLst>
+                      <p:childTnLst>
+                        <p:par>
+                          <p:cTn id="12" fill="hold">
+                            <p:stCondLst>
+                              <p:cond delay="0"/>
+                            </p:stCondLst>
+                            <p:childTnLst>
+                              <p:par>
+                                <p:cTn id="13" presetID="1" presetClass="entr" presetSubtype="0" fill="hold" grpId="0" nodeType="clickEffect">
+                                  <p:stCondLst>
+                                    <p:cond delay="0"/>
+                                  </p:stCondLst>
+                                  <p:childTnLst>
+                                    <p:set>
+                                      <p:cBhvr>
+                                        <p:cTn id="14" dur="1" fill="hold">
+                                          <p:stCondLst>
+                                            <p:cond delay="0"/>
+                                          </p:stCondLst>
+                                        </p:cTn>
+                                        <p:tgtEl>
+                                          <p:spTgt spid="3">
+                                            <p:txEl>
+                                              <p:pRg st="2" end="2"/>
+                                            </p:txEl>
+                                          </p:spTgt>
+                                        </p:tgtEl>
+                                        <p:attrNameLst>
+                                          <p:attrName>style.visibility</p:attrName>
+                                        </p:attrNameLst>
+                                      </p:cBhvr>
+                                      <p:to>
+                                        <p:strVal val="visible"/>
+                                      </p:to>
+                                    </p:set>
+                                  </p:childTnLst>
+                                </p:cTn>
+                              </p:par>
+                            </p:childTnLst>
+                          </p:cTn>
+                        </p:par>
+                      </p:childTnLst>
+                    </p:cTn>
+                  </p:par>
+                  <p:par>
+                    <p:cTn id="15" fill="hold">
+                      <p:stCondLst>
+                        <p:cond delay="indefinite"/>
+                      </p:stCondLst>
+                      <p:childTnLst>
+                        <p:par>
+                          <p:cTn id="16" fill="hold">
+                            <p:stCondLst>
+                              <p:cond delay="0"/>
+                            </p:stCondLst>
+                            <p:childTnLst>
+                              <p:par>
+                                <p:cTn id="17" presetID="1" presetClass="entr" presetSubtype="0" fill="hold" grpId="0" nodeType="clickEffect">
+                                  <p:stCondLst>
+                                    <p:cond delay="0"/>
+                                  </p:stCondLst>
+                                  <p:childTnLst>
+                                    <p:set>
+                                      <p:cBhvr>
+                                        <p:cTn id="18" dur="1" fill="hold">
+                                          <p:stCondLst>
+                                            <p:cond delay="0"/>
+                                          </p:stCondLst>
+                                        </p:cTn>
+                                        <p:tgtEl>
+                                          <p:spTgt spid="3">
+                                            <p:txEl>
+                                              <p:pRg st="3" end="3"/>
+                                            </p:txEl>
+                                          </p:spTgt>
+                                        </p:tgtEl>
+                                        <p:attrNameLst>
+                                          <p:attrName>style.visibility</p:attrName>
+                                        </p:attrNameLst>
+                                      </p:cBhvr>
+                                      <p:to>
+                                        <p:strVal val="visible"/>
+                                      </p:to>
+                                    </p:set>
+                                  </p:childTnLst>
+                                </p:cTn>
+                              </p:par>
+                            </p:childTnLst>
+                          </p:cTn>
+                        </p:par>
+                      </p:childTnLst>
+                    </p:cTn>
+                  </p:par>
+                </p:childTnLst>
+              </p:cTn>
+              <p:prevCondLst>
+                <p:cond evt="onPrev" delay="0">
+                  <p:tgtEl>
+                    <p:sldTgt/>
+                  </p:tgtEl>
+                </p:cond>
+              </p:prevCondLst>
+              <p:nextCondLst>
+                <p:cond evt="onNext" delay="0">
+                  <p:tgtEl>
+                    <p:sldTgt/>
+                  </p:tgtEl>
+                </p:cond>
+              </p:nextCondLst>
+            </p:seq>
+          </p:childTnLst>
+        </p:cTn>
+      </p:par>
+    </p:tnLst>
+    <p:bldLst>
+      <p:bldP spid="3" grpId="0" build="p"/>
+    </p:bldLst>
+  </p:timing>
 </p:sld>
 </file>
 

</xml_diff>